<commit_message>
Add Grok-generated images to pitch deck
- Generate 8 slide images via Grok Imagine API (generate_deck_images.py)
- Embed images on slides 1, 2, 3, 7, 9 as right-side accent visuals
- Images: hero, problem, solution, differentiator, vision scenes

Co-Authored-By: Claude Opus 4.6 (1M context) <noreply@anthropic.com>
</commit_message>
<xml_diff>
--- a/Lumina_Pitch_Deck.pptx
+++ b/Lumina_Pitch_Deck.pptx
@@ -3105,9 +3105,33 @@
         <p:nvPr/>
       </p:nvGrpSpPr>
       <p:grpSpPr/>
-      <p:sp>
-        <p:nvSpPr>
-          <p:cNvPr id="2" name="TextBox 1"/>
+      <p:pic>
+        <p:nvPicPr>
+          <p:cNvPr id="2" name="Picture 1" descr="slide1_hero.jpg"/>
+          <p:cNvPicPr>
+            <a:picLocks noChangeAspect="1"/>
+          </p:cNvPicPr>
+          <p:nvPr/>
+        </p:nvPicPr>
+        <p:blipFill>
+          <a:blip r:embed="rId2"/>
+          <a:stretch>
+            <a:fillRect/>
+          </a:stretch>
+        </p:blipFill>
+        <p:spPr>
+          <a:xfrm>
+            <a:off x="6858000" y="457200"/>
+            <a:ext cx="5029200" cy="5943600"/>
+          </a:xfrm>
+          <a:prstGeom prst="rect">
+            <a:avLst/>
+          </a:prstGeom>
+        </p:spPr>
+      </p:pic>
+      <p:sp>
+        <p:nvSpPr>
+          <p:cNvPr id="3" name="TextBox 2"/>
           <p:cNvSpPr txBox="1"/>
           <p:nvPr/>
         </p:nvSpPr>
@@ -3146,7 +3170,7 @@
       </p:sp>
       <p:sp>
         <p:nvSpPr>
-          <p:cNvPr id="3" name="TextBox 2"/>
+          <p:cNvPr id="4" name="TextBox 3"/>
           <p:cNvSpPr txBox="1"/>
           <p:nvPr/>
         </p:nvSpPr>
@@ -3185,7 +3209,7 @@
       </p:sp>
       <p:sp>
         <p:nvSpPr>
-          <p:cNvPr id="4" name="TextBox 3"/>
+          <p:cNvPr id="5" name="TextBox 4"/>
           <p:cNvSpPr txBox="1"/>
           <p:nvPr/>
         </p:nvSpPr>
@@ -3224,7 +3248,7 @@
       </p:sp>
       <p:sp>
         <p:nvSpPr>
-          <p:cNvPr id="5" name="Rectangle 4"/>
+          <p:cNvPr id="6" name="Rectangle 5"/>
           <p:cNvSpPr/>
           <p:nvPr/>
         </p:nvSpPr>
@@ -3267,7 +3291,7 @@
       </p:sp>
       <p:sp>
         <p:nvSpPr>
-          <p:cNvPr id="6" name="TextBox 5"/>
+          <p:cNvPr id="7" name="TextBox 6"/>
           <p:cNvSpPr txBox="1"/>
           <p:nvPr/>
         </p:nvSpPr>
@@ -3594,9 +3618,33 @@
         <p:nvPr/>
       </p:nvGrpSpPr>
       <p:grpSpPr/>
-      <p:sp>
-        <p:nvSpPr>
-          <p:cNvPr id="2" name="Rectangle 1"/>
+      <p:pic>
+        <p:nvPicPr>
+          <p:cNvPr id="2" name="Picture 1" descr="slide2_problem.jpg"/>
+          <p:cNvPicPr>
+            <a:picLocks noChangeAspect="1"/>
+          </p:cNvPicPr>
+          <p:nvPr/>
+        </p:nvPicPr>
+        <p:blipFill>
+          <a:blip r:embed="rId2"/>
+          <a:stretch>
+            <a:fillRect/>
+          </a:stretch>
+        </p:blipFill>
+        <p:spPr>
+          <a:xfrm>
+            <a:off x="6858000" y="1371600"/>
+            <a:ext cx="5029200" cy="5029200"/>
+          </a:xfrm>
+          <a:prstGeom prst="rect">
+            <a:avLst/>
+          </a:prstGeom>
+        </p:spPr>
+      </p:pic>
+      <p:sp>
+        <p:nvSpPr>
+          <p:cNvPr id="3" name="Rectangle 2"/>
           <p:cNvSpPr/>
           <p:nvPr/>
         </p:nvSpPr>
@@ -3639,7 +3687,7 @@
       </p:sp>
       <p:sp>
         <p:nvSpPr>
-          <p:cNvPr id="3" name="TextBox 2"/>
+          <p:cNvPr id="4" name="TextBox 3"/>
           <p:cNvSpPr txBox="1"/>
           <p:nvPr/>
         </p:nvSpPr>
@@ -3678,7 +3726,7 @@
       </p:sp>
       <p:sp>
         <p:nvSpPr>
-          <p:cNvPr id="4" name="TextBox 3"/>
+          <p:cNvPr id="5" name="TextBox 4"/>
           <p:cNvSpPr txBox="1"/>
           <p:nvPr/>
         </p:nvSpPr>
@@ -3809,7 +3857,7 @@
       </p:sp>
       <p:sp>
         <p:nvSpPr>
-          <p:cNvPr id="5" name="TextBox 4"/>
+          <p:cNvPr id="6" name="TextBox 5"/>
           <p:cNvSpPr txBox="1"/>
           <p:nvPr/>
         </p:nvSpPr>
@@ -3872,9 +3920,33 @@
         <p:nvPr/>
       </p:nvGrpSpPr>
       <p:grpSpPr/>
-      <p:sp>
-        <p:nvSpPr>
-          <p:cNvPr id="2" name="Rectangle 1"/>
+      <p:pic>
+        <p:nvPicPr>
+          <p:cNvPr id="2" name="Picture 1" descr="slide3_solution.jpg"/>
+          <p:cNvPicPr>
+            <a:picLocks noChangeAspect="1"/>
+          </p:cNvPicPr>
+          <p:nvPr/>
+        </p:nvPicPr>
+        <p:blipFill>
+          <a:blip r:embed="rId2"/>
+          <a:stretch>
+            <a:fillRect/>
+          </a:stretch>
+        </p:blipFill>
+        <p:spPr>
+          <a:xfrm>
+            <a:off x="6858000" y="1371600"/>
+            <a:ext cx="5029200" cy="5029200"/>
+          </a:xfrm>
+          <a:prstGeom prst="rect">
+            <a:avLst/>
+          </a:prstGeom>
+        </p:spPr>
+      </p:pic>
+      <p:sp>
+        <p:nvSpPr>
+          <p:cNvPr id="3" name="Rectangle 2"/>
           <p:cNvSpPr/>
           <p:nvPr/>
         </p:nvSpPr>
@@ -3917,7 +3989,7 @@
       </p:sp>
       <p:sp>
         <p:nvSpPr>
-          <p:cNvPr id="3" name="TextBox 2"/>
+          <p:cNvPr id="4" name="TextBox 3"/>
           <p:cNvSpPr txBox="1"/>
           <p:nvPr/>
         </p:nvSpPr>
@@ -3956,7 +4028,7 @@
       </p:sp>
       <p:sp>
         <p:nvSpPr>
-          <p:cNvPr id="4" name="TextBox 3"/>
+          <p:cNvPr id="5" name="TextBox 4"/>
           <p:cNvSpPr txBox="1"/>
           <p:nvPr/>
         </p:nvSpPr>
@@ -3995,7 +4067,7 @@
       </p:sp>
       <p:sp>
         <p:nvSpPr>
-          <p:cNvPr id="5" name="TextBox 4"/>
+          <p:cNvPr id="6" name="TextBox 5"/>
           <p:cNvSpPr txBox="1"/>
           <p:nvPr/>
         </p:nvSpPr>
@@ -7538,9 +7610,33 @@
         <p:nvPr/>
       </p:nvGrpSpPr>
       <p:grpSpPr/>
-      <p:sp>
-        <p:nvSpPr>
-          <p:cNvPr id="2" name="Rectangle 1"/>
+      <p:pic>
+        <p:nvPicPr>
+          <p:cNvPr id="2" name="Picture 1" descr="slide7_differentiator.jpg"/>
+          <p:cNvPicPr>
+            <a:picLocks noChangeAspect="1"/>
+          </p:cNvPicPr>
+          <p:nvPr/>
+        </p:nvPicPr>
+        <p:blipFill>
+          <a:blip r:embed="rId2"/>
+          <a:stretch>
+            <a:fillRect/>
+          </a:stretch>
+        </p:blipFill>
+        <p:spPr>
+          <a:xfrm>
+            <a:off x="7132320" y="1371600"/>
+            <a:ext cx="4754880" cy="5029200"/>
+          </a:xfrm>
+          <a:prstGeom prst="rect">
+            <a:avLst/>
+          </a:prstGeom>
+        </p:spPr>
+      </p:pic>
+      <p:sp>
+        <p:nvSpPr>
+          <p:cNvPr id="3" name="Rectangle 2"/>
           <p:cNvSpPr/>
           <p:nvPr/>
         </p:nvSpPr>
@@ -7583,7 +7679,7 @@
       </p:sp>
       <p:sp>
         <p:nvSpPr>
-          <p:cNvPr id="3" name="TextBox 2"/>
+          <p:cNvPr id="4" name="TextBox 3"/>
           <p:cNvSpPr txBox="1"/>
           <p:nvPr/>
         </p:nvSpPr>
@@ -7622,7 +7718,7 @@
       </p:sp>
       <p:sp>
         <p:nvSpPr>
-          <p:cNvPr id="4" name="Rectangle 3"/>
+          <p:cNvPr id="5" name="Rectangle 4"/>
           <p:cNvSpPr/>
           <p:nvPr/>
         </p:nvSpPr>
@@ -7665,7 +7761,7 @@
       </p:sp>
       <p:sp>
         <p:nvSpPr>
-          <p:cNvPr id="5" name="TextBox 4"/>
+          <p:cNvPr id="6" name="TextBox 5"/>
           <p:cNvSpPr txBox="1"/>
           <p:nvPr/>
         </p:nvSpPr>
@@ -7704,7 +7800,7 @@
       </p:sp>
       <p:sp>
         <p:nvSpPr>
-          <p:cNvPr id="6" name="TextBox 5"/>
+          <p:cNvPr id="7" name="TextBox 6"/>
           <p:cNvSpPr txBox="1"/>
           <p:nvPr/>
         </p:nvSpPr>
@@ -7743,7 +7839,7 @@
       </p:sp>
       <p:sp>
         <p:nvSpPr>
-          <p:cNvPr id="7" name="Rectangle 6"/>
+          <p:cNvPr id="8" name="Rectangle 7"/>
           <p:cNvSpPr/>
           <p:nvPr/>
         </p:nvSpPr>
@@ -7786,7 +7882,7 @@
       </p:sp>
       <p:sp>
         <p:nvSpPr>
-          <p:cNvPr id="8" name="TextBox 7"/>
+          <p:cNvPr id="9" name="TextBox 8"/>
           <p:cNvSpPr txBox="1"/>
           <p:nvPr/>
         </p:nvSpPr>
@@ -7825,7 +7921,7 @@
       </p:sp>
       <p:sp>
         <p:nvSpPr>
-          <p:cNvPr id="9" name="TextBox 8"/>
+          <p:cNvPr id="10" name="TextBox 9"/>
           <p:cNvSpPr txBox="1"/>
           <p:nvPr/>
         </p:nvSpPr>
@@ -7864,7 +7960,7 @@
       </p:sp>
       <p:sp>
         <p:nvSpPr>
-          <p:cNvPr id="10" name="Rectangle 9"/>
+          <p:cNvPr id="11" name="Rectangle 10"/>
           <p:cNvSpPr/>
           <p:nvPr/>
         </p:nvSpPr>
@@ -7907,7 +8003,7 @@
       </p:sp>
       <p:sp>
         <p:nvSpPr>
-          <p:cNvPr id="11" name="TextBox 10"/>
+          <p:cNvPr id="12" name="TextBox 11"/>
           <p:cNvSpPr txBox="1"/>
           <p:nvPr/>
         </p:nvSpPr>
@@ -7946,7 +8042,7 @@
       </p:sp>
       <p:sp>
         <p:nvSpPr>
-          <p:cNvPr id="12" name="TextBox 11"/>
+          <p:cNvPr id="13" name="TextBox 12"/>
           <p:cNvSpPr txBox="1"/>
           <p:nvPr/>
         </p:nvSpPr>
@@ -7985,7 +8081,7 @@
       </p:sp>
       <p:sp>
         <p:nvSpPr>
-          <p:cNvPr id="13" name="Rectangle 12"/>
+          <p:cNvPr id="14" name="Rectangle 13"/>
           <p:cNvSpPr/>
           <p:nvPr/>
         </p:nvSpPr>
@@ -8028,7 +8124,7 @@
       </p:sp>
       <p:sp>
         <p:nvSpPr>
-          <p:cNvPr id="14" name="TextBox 13"/>
+          <p:cNvPr id="15" name="TextBox 14"/>
           <p:cNvSpPr txBox="1"/>
           <p:nvPr/>
         </p:nvSpPr>
@@ -8067,7 +8163,7 @@
       </p:sp>
       <p:sp>
         <p:nvSpPr>
-          <p:cNvPr id="15" name="TextBox 14"/>
+          <p:cNvPr id="16" name="TextBox 15"/>
           <p:cNvSpPr txBox="1"/>
           <p:nvPr/>
         </p:nvSpPr>
@@ -8106,7 +8202,7 @@
       </p:sp>
       <p:sp>
         <p:nvSpPr>
-          <p:cNvPr id="16" name="Rectangle 15"/>
+          <p:cNvPr id="17" name="Rectangle 16"/>
           <p:cNvSpPr/>
           <p:nvPr/>
         </p:nvSpPr>
@@ -8149,7 +8245,7 @@
       </p:sp>
       <p:sp>
         <p:nvSpPr>
-          <p:cNvPr id="17" name="TextBox 16"/>
+          <p:cNvPr id="18" name="TextBox 17"/>
           <p:cNvSpPr txBox="1"/>
           <p:nvPr/>
         </p:nvSpPr>
@@ -8188,7 +8284,7 @@
       </p:sp>
       <p:sp>
         <p:nvSpPr>
-          <p:cNvPr id="18" name="TextBox 17"/>
+          <p:cNvPr id="19" name="TextBox 18"/>
           <p:cNvSpPr txBox="1"/>
           <p:nvPr/>
         </p:nvSpPr>
@@ -9487,9 +9583,33 @@
         <p:nvPr/>
       </p:nvGrpSpPr>
       <p:grpSpPr/>
-      <p:sp>
-        <p:nvSpPr>
-          <p:cNvPr id="2" name="Rectangle 1"/>
+      <p:pic>
+        <p:nvPicPr>
+          <p:cNvPr id="2" name="Picture 1" descr="slide9_vision.jpg"/>
+          <p:cNvPicPr>
+            <a:picLocks noChangeAspect="1"/>
+          </p:cNvPicPr>
+          <p:nvPr/>
+        </p:nvPicPr>
+        <p:blipFill>
+          <a:blip r:embed="rId2"/>
+          <a:stretch>
+            <a:fillRect/>
+          </a:stretch>
+        </p:blipFill>
+        <p:spPr>
+          <a:xfrm>
+            <a:off x="6858000" y="1371600"/>
+            <a:ext cx="5029200" cy="5029200"/>
+          </a:xfrm>
+          <a:prstGeom prst="rect">
+            <a:avLst/>
+          </a:prstGeom>
+        </p:spPr>
+      </p:pic>
+      <p:sp>
+        <p:nvSpPr>
+          <p:cNvPr id="3" name="Rectangle 2"/>
           <p:cNvSpPr/>
           <p:nvPr/>
         </p:nvSpPr>
@@ -9532,7 +9652,7 @@
       </p:sp>
       <p:sp>
         <p:nvSpPr>
-          <p:cNvPr id="3" name="TextBox 2"/>
+          <p:cNvPr id="4" name="TextBox 3"/>
           <p:cNvSpPr txBox="1"/>
           <p:nvPr/>
         </p:nvSpPr>
@@ -9571,7 +9691,7 @@
       </p:sp>
       <p:sp>
         <p:nvSpPr>
-          <p:cNvPr id="4" name="TextBox 3"/>
+          <p:cNvPr id="5" name="TextBox 4"/>
           <p:cNvSpPr txBox="1"/>
           <p:nvPr/>
         </p:nvSpPr>

</xml_diff>